<commit_message>
Slide 1 de Motos Roll con una foto real del taller
Una moto sobre el elevador, sacada de la galeria del propio sitio. Sin
la foto el carrusel arrancaba con una frase suelta y no conectaba.

Co-Authored-By: Claude Opus 5 <noreply@anthropic.com>
</commit_message>
<xml_diff>
--- a/contenido/carruseles/05-motos-roll/editable-canva.pptx
+++ b/contenido/carruseles/05-motos-roll/editable-canva.pptx
@@ -3099,9 +3099,33 @@
         <p:nvPr/>
       </p:nvGrpSpPr>
       <p:grpSpPr/>
-      <p:sp>
-        <p:nvSpPr>
-          <p:cNvPr id="2" name="Rounded Rectangle 1"/>
+      <p:pic>
+        <p:nvPicPr>
+          <p:cNvPr id="2" name="Picture 1" descr="image.jpg"/>
+          <p:cNvPicPr>
+            <a:picLocks noChangeAspect="1"/>
+          </p:cNvPicPr>
+          <p:nvPr/>
+        </p:nvPicPr>
+        <p:blipFill>
+          <a:blip r:embed="rId2"/>
+          <a:stretch>
+            <a:fillRect/>
+          </a:stretch>
+        </p:blipFill>
+        <p:spPr>
+          <a:xfrm>
+            <a:off x="0" y="0"/>
+            <a:ext cx="10287000" cy="12858750"/>
+          </a:xfrm>
+          <a:prstGeom prst="rect">
+            <a:avLst/>
+          </a:prstGeom>
+        </p:spPr>
+      </p:pic>
+      <p:sp>
+        <p:nvSpPr>
+          <p:cNvPr id="3" name="Rounded Rectangle 2"/>
           <p:cNvSpPr/>
           <p:nvPr/>
         </p:nvSpPr>
@@ -3147,7 +3171,7 @@
       </p:sp>
       <p:sp>
         <p:nvSpPr>
-          <p:cNvPr id="3" name="Rectangle 2"/>
+          <p:cNvPr id="4" name="Rectangle 3"/>
           <p:cNvSpPr/>
           <p:nvPr/>
         </p:nvSpPr>
@@ -3160,7 +3184,7 @@
             <a:avLst/>
           </a:prstGeom>
           <a:solidFill>
-            <a:srgbClr val="A8E1F8"/>
+            <a:srgbClr val="73CFF2"/>
           </a:solidFill>
           <a:ln>
             <a:noFill/>
@@ -3191,7 +3215,7 @@
       </p:sp>
       <p:sp>
         <p:nvSpPr>
-          <p:cNvPr id="4" name="TextBox 3"/>
+          <p:cNvPr id="5" name="TextBox 4"/>
           <p:cNvSpPr txBox="1"/>
           <p:nvPr/>
         </p:nvSpPr>
@@ -3219,7 +3243,7 @@
             <a:r>
               <a:rPr sz="6900" b="1" spc="-206">
                 <a:solidFill>
-                  <a:srgbClr val="0A1B33"/>
+                  <a:srgbClr val="FFFFFF"/>
                 </a:solidFill>
                 <a:latin typeface="Bricolage Grotesque"/>
               </a:rPr>
@@ -3235,7 +3259,7 @@
             <a:r>
               <a:rPr sz="6900" b="1" spc="-206">
                 <a:solidFill>
-                  <a:srgbClr val="0A1B33"/>
+                  <a:srgbClr val="FFFFFF"/>
                 </a:solidFill>
                 <a:latin typeface="Bricolage Grotesque"/>
               </a:rPr>
@@ -3251,7 +3275,7 @@
             <a:r>
               <a:rPr sz="6900" b="1" spc="-206">
                 <a:solidFill>
-                  <a:srgbClr val="0A1B33"/>
+                  <a:srgbClr val="FFFFFF"/>
                 </a:solidFill>
                 <a:latin typeface="Bricolage Grotesque"/>
               </a:rPr>
@@ -3260,7 +3284,7 @@
             <a:r>
               <a:rPr sz="6900" b="1" spc="-206">
                 <a:solidFill>
-                  <a:srgbClr val="0A1B33"/>
+                  <a:srgbClr val="FFFFFF"/>
                 </a:solidFill>
                 <a:latin typeface="Bricolage Grotesque"/>
               </a:rPr>
@@ -3271,14 +3295,14 @@
       </p:sp>
       <p:pic>
         <p:nvPicPr>
-          <p:cNvPr id="5" name="Picture 4" descr="image.png"/>
+          <p:cNvPr id="6" name="Picture 5" descr="image.png"/>
           <p:cNvPicPr>
             <a:picLocks noChangeAspect="1"/>
           </p:cNvPicPr>
           <p:nvPr/>
         </p:nvPicPr>
         <p:blipFill>
-          <a:blip r:embed="rId2"/>
+          <a:blip r:embed="rId3"/>
           <a:stretch>
             <a:fillRect/>
           </a:stretch>
@@ -3295,7 +3319,7 @@
       </p:pic>
       <p:sp>
         <p:nvSpPr>
-          <p:cNvPr id="6" name="TextBox 5"/>
+          <p:cNvPr id="7" name="TextBox 6"/>
           <p:cNvSpPr txBox="1"/>
           <p:nvPr/>
         </p:nvSpPr>
@@ -3323,7 +3347,7 @@
             <a:r>
               <a:rPr sz="1800" b="1" spc="252">
                 <a:solidFill>
-                  <a:srgbClr val="1657D0"/>
+                  <a:srgbClr val="8FD8F5"/>
                 </a:solidFill>
                 <a:latin typeface="Figtree"/>
               </a:rPr>
@@ -3332,7 +3356,7 @@
             <a:r>
               <a:rPr sz="1800" b="1" spc="252">
                 <a:solidFill>
-                  <a:srgbClr val="1657D0"/>
+                  <a:srgbClr val="8FD8F5"/>
                 </a:solidFill>
                 <a:latin typeface="Figtree"/>
               </a:rPr>

</xml_diff>

<commit_message>
Motos Roll queda en 3 slides y build.py limpia los PNG viejos
Se saco el bloque de color: estiraba una idea que entra en tres slides.
Al achicar un carrusel, los PNG de los slides borrados seguian en la
carpeta y se colaban en la hoja de contacto y en el PPTX.

Co-Authored-By: Claude Opus 5 <noreply@anthropic.com>
</commit_message>
<xml_diff>
--- a/contenido/carruseles/05-motos-roll/editable-canva.pptx
+++ b/contenido/carruseles/05-motos-roll/editable-canva.pptx
@@ -8,7 +8,6 @@
     <p:sldId id="256" r:id="rId7"/>
     <p:sldId id="257" r:id="rId8"/>
     <p:sldId id="258" r:id="rId9"/>
-    <p:sldId id="259" r:id="rId10"/>
   </p:sldIdLst>
   <p:sldSz cx="10287000" cy="12858750" type="screen4x3"/>
   <p:notesSz cx="6858000" cy="9144000"/>
@@ -3178,7 +3177,7 @@
         <p:spPr>
           <a:xfrm>
             <a:off x="838200" y="7336976"/>
-            <a:ext cx="4259758" cy="315468"/>
+            <a:ext cx="5368230" cy="315468"/>
           </a:xfrm>
           <a:prstGeom prst="rect">
             <a:avLst/>
@@ -3247,7 +3246,7 @@
                 </a:solidFill>
                 <a:latin typeface="Bricolage Grotesque"/>
               </a:rPr>
-              <a:t xml:space="preserve">El taller ya hacía</a:t>
+              <a:t xml:space="preserve">El trabajo que</a:t>
             </a:r>
           </a:p>
           <a:p>
@@ -3263,7 +3262,7 @@
                 </a:solidFill>
                 <a:latin typeface="Bricolage Grotesque"/>
               </a:rPr>
-              <a:t xml:space="preserve">un trabajo que</a:t>
+              <a:t xml:space="preserve">mejor paga no</a:t>
             </a:r>
           </a:p>
           <a:p>
@@ -3279,7 +3278,7 @@
                 </a:solidFill>
                 <a:latin typeface="Bricolage Grotesque"/>
               </a:rPr>
-              <a:t xml:space="preserve">nadie sabía</a:t>
+              <a:t xml:space="preserve">estaba escrito</a:t>
             </a:r>
             <a:r>
               <a:rPr sz="6900" b="1" spc="-206">
@@ -3379,7 +3378,7 @@
     <p:bg>
       <p:bgPr>
         <a:solidFill>
-          <a:srgbClr val="00A8E8"/>
+          <a:srgbClr val="F2F6FC"/>
         </a:solidFill>
         <a:effectLst/>
       </p:bgPr>
@@ -3408,7 +3407,7 @@
             </a:avLst>
           </a:prstGeom>
           <a:solidFill>
-            <a:srgbClr val="062A4D"/>
+            <a:srgbClr val="00A8E8"/>
           </a:solidFill>
           <a:ln>
             <a:noFill/>
@@ -3467,7 +3466,7 @@
             <a:r>
               <a:rPr sz="1650" b="1" spc="264">
                 <a:solidFill>
-                  <a:srgbClr val="063E63"/>
+                  <a:srgbClr val="1657D0"/>
                 </a:solidFill>
                 <a:latin typeface="Figtree"/>
               </a:rPr>
@@ -3478,14 +3477,152 @@
       </p:sp>
       <p:sp>
         <p:nvSpPr>
-          <p:cNvPr id="4" name="TextBox 3"/>
+          <p:cNvPr id="4" name="Rounded Rectangle 3"/>
+          <p:cNvSpPr/>
+          <p:nvPr/>
+        </p:nvSpPr>
+        <p:spPr>
+          <a:xfrm>
+            <a:off x="5638800" y="2964805"/>
+            <a:ext cx="495300" cy="38100"/>
+          </a:xfrm>
+          <a:prstGeom prst="roundRect">
+            <a:avLst>
+              <a:gd name="adj" fmla="val 50000"/>
+            </a:avLst>
+          </a:prstGeom>
+          <a:solidFill>
+            <a:srgbClr val="00A8E8"/>
+          </a:solidFill>
+          <a:ln>
+            <a:noFill/>
+          </a:ln>
+          <a:effectLst/>
+        </p:spPr>
+        <p:style>
+          <a:lnRef idx="1">
+            <a:schemeClr val="accent1"/>
+          </a:lnRef>
+          <a:fillRef idx="3">
+            <a:schemeClr val="accent1"/>
+          </a:fillRef>
+          <a:effectRef idx="2">
+            <a:schemeClr val="accent1"/>
+          </a:effectRef>
+          <a:fontRef idx="minor">
+            <a:schemeClr val="lt1"/>
+          </a:fontRef>
+        </p:style>
+        <p:txBody>
+          <a:bodyPr rtlCol="0" anchor="ctr"/>
+          <a:lstStyle/>
+          <a:p>
+            <a:pPr algn="ctr"/>
+          </a:p>
+        </p:txBody>
+      </p:sp>
+      <p:sp>
+        <p:nvSpPr>
+          <p:cNvPr id="5" name="Rounded Rectangle 4"/>
+          <p:cNvSpPr/>
+          <p:nvPr/>
+        </p:nvSpPr>
+        <p:spPr>
+          <a:xfrm>
+            <a:off x="5638800" y="5938242"/>
+            <a:ext cx="495300" cy="38100"/>
+          </a:xfrm>
+          <a:prstGeom prst="roundRect">
+            <a:avLst>
+              <a:gd name="adj" fmla="val 50000"/>
+            </a:avLst>
+          </a:prstGeom>
+          <a:solidFill>
+            <a:srgbClr val="00A8E8"/>
+          </a:solidFill>
+          <a:ln>
+            <a:noFill/>
+          </a:ln>
+          <a:effectLst/>
+        </p:spPr>
+        <p:style>
+          <a:lnRef idx="1">
+            <a:schemeClr val="accent1"/>
+          </a:lnRef>
+          <a:fillRef idx="3">
+            <a:schemeClr val="accent1"/>
+          </a:fillRef>
+          <a:effectRef idx="2">
+            <a:schemeClr val="accent1"/>
+          </a:effectRef>
+          <a:fontRef idx="minor">
+            <a:schemeClr val="lt1"/>
+          </a:fontRef>
+        </p:style>
+        <p:txBody>
+          <a:bodyPr rtlCol="0" anchor="ctr"/>
+          <a:lstStyle/>
+          <a:p>
+            <a:pPr algn="ctr"/>
+          </a:p>
+        </p:txBody>
+      </p:sp>
+      <p:sp>
+        <p:nvSpPr>
+          <p:cNvPr id="6" name="Rounded Rectangle 5"/>
+          <p:cNvSpPr/>
+          <p:nvPr/>
+        </p:nvSpPr>
+        <p:spPr>
+          <a:xfrm>
+            <a:off x="5638800" y="8263681"/>
+            <a:ext cx="495300" cy="38100"/>
+          </a:xfrm>
+          <a:prstGeom prst="roundRect">
+            <a:avLst>
+              <a:gd name="adj" fmla="val 50000"/>
+            </a:avLst>
+          </a:prstGeom>
+          <a:solidFill>
+            <a:srgbClr val="00A8E8"/>
+          </a:solidFill>
+          <a:ln>
+            <a:noFill/>
+          </a:ln>
+          <a:effectLst/>
+        </p:spPr>
+        <p:style>
+          <a:lnRef idx="1">
+            <a:schemeClr val="accent1"/>
+          </a:lnRef>
+          <a:fillRef idx="3">
+            <a:schemeClr val="accent1"/>
+          </a:fillRef>
+          <a:effectRef idx="2">
+            <a:schemeClr val="accent1"/>
+          </a:effectRef>
+          <a:fontRef idx="minor">
+            <a:schemeClr val="lt1"/>
+          </a:fontRef>
+        </p:style>
+        <p:txBody>
+          <a:bodyPr rtlCol="0" anchor="ctr"/>
+          <a:lstStyle/>
+          <a:p>
+            <a:pPr algn="ctr"/>
+          </a:p>
+        </p:txBody>
+      </p:sp>
+      <p:sp>
+        <p:nvSpPr>
+          <p:cNvPr id="7" name="TextBox 6"/>
           <p:cNvSpPr txBox="1"/>
           <p:nvPr/>
         </p:nvSpPr>
         <p:spPr>
           <a:xfrm>
-            <a:off x="838200" y="4706689"/>
-            <a:ext cx="9182100" cy="3340447"/>
+            <a:off x="6324600" y="2793355"/>
+            <a:ext cx="3181350" cy="820042"/>
           </a:xfrm>
           <a:prstGeom prst="rect">
             <a:avLst/>
@@ -3493,63 +3630,226 @@
           <a:noFill/>
         </p:spPr>
         <p:txBody>
-          <a:bodyPr wrap="none" lIns="0" rIns="0" tIns="0" bIns="0" anchor="t">
+          <a:bodyPr wrap="square" lIns="0" rIns="0" tIns="0" bIns="0" anchor="t">
             <a:noAutofit/>
           </a:bodyPr>
           <a:lstStyle/>
           <a:p>
             <a:pPr algn="l">
               <a:lnSpc>
-                <a:spcPts val="8568"/>
+                <a:spcPts val="2929"/>
               </a:lnSpc>
             </a:pPr>
             <a:r>
-              <a:rPr sz="8400" b="1" spc="-252">
+              <a:rPr sz="2325" b="1">
                 <a:solidFill>
-                  <a:srgbClr val="062A4D"/>
+                  <a:srgbClr val="0A1B33"/>
                 </a:solidFill>
-                <a:latin typeface="Bricolage Grotesque"/>
+                <a:latin typeface="Figtree"/>
               </a:rPr>
-              <a:t xml:space="preserve">Si no está</a:t>
-            </a:r>
-          </a:p>
+              <a:t xml:space="preserve">Presupuestos para las aseguradoras</a:t>
+            </a:r>
+          </a:p>
+        </p:txBody>
+      </p:sp>
+      <p:sp>
+        <p:nvSpPr>
+          <p:cNvPr id="8" name="TextBox 7"/>
+          <p:cNvSpPr txBox="1"/>
+          <p:nvPr/>
+        </p:nvSpPr>
+        <p:spPr>
+          <a:xfrm>
+            <a:off x="6324600" y="5766792"/>
+            <a:ext cx="3181350" cy="820042"/>
+          </a:xfrm>
+          <a:prstGeom prst="rect">
+            <a:avLst/>
+          </a:prstGeom>
+          <a:noFill/>
+        </p:spPr>
+        <p:txBody>
+          <a:bodyPr wrap="square" lIns="0" rIns="0" tIns="0" bIns="0" anchor="t">
+            <a:noAutofit/>
+          </a:bodyPr>
+          <a:lstStyle/>
           <a:p>
             <a:pPr algn="l">
               <a:lnSpc>
-                <a:spcPts val="8568"/>
+                <a:spcPts val="2929"/>
               </a:lnSpc>
             </a:pPr>
             <a:r>
-              <a:rPr sz="8400" b="1" spc="-252">
+              <a:rPr sz="2325" b="1">
                 <a:solidFill>
-                  <a:srgbClr val="062A4D"/>
+                  <a:srgbClr val="0A1B33"/>
                 </a:solidFill>
-                <a:latin typeface="Bricolage Grotesque"/>
+                <a:latin typeface="Figtree"/>
               </a:rPr>
-              <a:t xml:space="preserve">escrito,</a:t>
-            </a:r>
-          </a:p>
+              <a:t xml:space="preserve">Informe con fotos de cada daño</a:t>
+            </a:r>
+          </a:p>
+        </p:txBody>
+      </p:sp>
+      <p:sp>
+        <p:nvSpPr>
+          <p:cNvPr id="9" name="TextBox 8"/>
+          <p:cNvSpPr txBox="1"/>
+          <p:nvPr/>
+        </p:nvSpPr>
+        <p:spPr>
+          <a:xfrm>
+            <a:off x="6324600" y="8092231"/>
+            <a:ext cx="3181350" cy="820042"/>
+          </a:xfrm>
+          <a:prstGeom prst="rect">
+            <a:avLst/>
+          </a:prstGeom>
+          <a:noFill/>
+        </p:spPr>
+        <p:txBody>
+          <a:bodyPr wrap="square" lIns="0" rIns="0" tIns="0" bIns="0" anchor="t">
+            <a:noAutofit/>
+          </a:bodyPr>
+          <a:lstStyle/>
           <a:p>
             <a:pPr algn="l">
               <a:lnSpc>
-                <a:spcPts val="8568"/>
+                <a:spcPts val="2929"/>
               </a:lnSpc>
             </a:pPr>
             <a:r>
-              <a:rPr sz="8400" b="1" spc="-252">
+              <a:rPr sz="2325" b="1">
                 <a:solidFill>
-                  <a:srgbClr val="062A4D"/>
+                  <a:srgbClr val="0A1B33"/>
                 </a:solidFill>
-                <a:latin typeface="Bricolage Grotesque"/>
+                <a:latin typeface="Figtree"/>
               </a:rPr>
-              <a:t xml:space="preserve">no existe.</a:t>
+              <a:t xml:space="preserve">“Atendemos siniestros de toda la zona oeste”</a:t>
+            </a:r>
+          </a:p>
+        </p:txBody>
+      </p:sp>
+      <p:sp>
+        <p:nvSpPr>
+          <p:cNvPr id="10" name="TextBox 9"/>
+          <p:cNvSpPr txBox="1"/>
+          <p:nvPr/>
+        </p:nvSpPr>
+        <p:spPr>
+          <a:xfrm>
+            <a:off x="6324600" y="3613398"/>
+            <a:ext cx="3181350" cy="1696194"/>
+          </a:xfrm>
+          <a:prstGeom prst="rect">
+            <a:avLst/>
+          </a:prstGeom>
+          <a:noFill/>
+        </p:spPr>
+        <p:txBody>
+          <a:bodyPr wrap="square" lIns="0" rIns="0" tIns="0" bIns="0" anchor="t">
+            <a:noAutofit/>
+          </a:bodyPr>
+          <a:lstStyle/>
+          <a:p>
+            <a:pPr algn="l">
+              <a:lnSpc>
+                <a:spcPts val="2551"/>
+              </a:lnSpc>
+            </a:pPr>
+            <a:r>
+              <a:rPr sz="2025" b="0">
+                <a:solidFill>
+                  <a:srgbClr val="46526B"/>
+                </a:solidFill>
+                <a:latin typeface="Figtree"/>
+              </a:rPr>
+              <a:t xml:space="preserve">Mano de obra y repuestos discriminados, en el formato que pide la compañía. Con su propio botón.</a:t>
+            </a:r>
+          </a:p>
+        </p:txBody>
+      </p:sp>
+      <p:sp>
+        <p:nvSpPr>
+          <p:cNvPr id="11" name="TextBox 10"/>
+          <p:cNvSpPr txBox="1"/>
+          <p:nvPr/>
+        </p:nvSpPr>
+        <p:spPr>
+          <a:xfrm>
+            <a:off x="6324600" y="6586835"/>
+            <a:ext cx="3181350" cy="1048196"/>
+          </a:xfrm>
+          <a:prstGeom prst="rect">
+            <a:avLst/>
+          </a:prstGeom>
+          <a:noFill/>
+        </p:spPr>
+        <p:txBody>
+          <a:bodyPr wrap="square" lIns="0" rIns="0" tIns="0" bIns="0" anchor="t">
+            <a:noAutofit/>
+          </a:bodyPr>
+          <a:lstStyle/>
+          <a:p>
+            <a:pPr algn="l">
+              <a:lnSpc>
+                <a:spcPts val="2551"/>
+              </a:lnSpc>
+            </a:pPr>
+            <a:r>
+              <a:rPr sz="2025" b="0">
+                <a:solidFill>
+                  <a:srgbClr val="46526B"/>
+                </a:solidFill>
+                <a:latin typeface="Figtree"/>
+              </a:rPr>
+              <a:t xml:space="preserve">Para que la aseguradora autorice la reparación sin idas y vueltas.</a:t>
+            </a:r>
+          </a:p>
+        </p:txBody>
+      </p:sp>
+      <p:sp>
+        <p:nvSpPr>
+          <p:cNvPr id="12" name="TextBox 11"/>
+          <p:cNvSpPr txBox="1"/>
+          <p:nvPr/>
+        </p:nvSpPr>
+        <p:spPr>
+          <a:xfrm>
+            <a:off x="6324600" y="8912274"/>
+            <a:ext cx="3181350" cy="1048196"/>
+          </a:xfrm>
+          <a:prstGeom prst="rect">
+            <a:avLst/>
+          </a:prstGeom>
+          <a:noFill/>
+        </p:spPr>
+        <p:txBody>
+          <a:bodyPr wrap="square" lIns="0" rIns="0" tIns="0" bIns="0" anchor="t">
+            <a:noAutofit/>
+          </a:bodyPr>
+          <a:lstStyle/>
+          <a:p>
+            <a:pPr algn="l">
+              <a:lnSpc>
+                <a:spcPts val="2551"/>
+              </a:lnSpc>
+            </a:pPr>
+            <a:r>
+              <a:rPr sz="2025" b="0">
+                <a:solidFill>
+                  <a:srgbClr val="46526B"/>
+                </a:solidFill>
+                <a:latin typeface="Figtree"/>
+              </a:rPr>
+              <a:t xml:space="preserve">Ahora está escrito en la página, y no sólo en la cabeza del mecánico.</a:t>
             </a:r>
           </a:p>
         </p:txBody>
       </p:sp>
       <p:pic>
         <p:nvPicPr>
-          <p:cNvPr id="5" name="Picture 4" descr="image.png"/>
+          <p:cNvPr id="13" name="Picture 12" descr="image.png"/>
           <p:cNvPicPr>
             <a:picLocks noChangeAspect="1"/>
           </p:cNvPicPr>
@@ -3563,17 +3863,41 @@
         </p:blipFill>
         <p:spPr>
           <a:xfrm>
-            <a:off x="838200" y="11582400"/>
-            <a:ext cx="438150" cy="438150"/>
+            <a:off x="674515" y="1954124"/>
+            <a:ext cx="4632668" cy="8769525"/>
           </a:xfrm>
           <a:prstGeom prst="rect">
             <a:avLst/>
           </a:prstGeom>
         </p:spPr>
       </p:pic>
-      <p:sp>
-        <p:nvSpPr>
-          <p:cNvPr id="6" name="TextBox 5"/>
+      <p:pic>
+        <p:nvPicPr>
+          <p:cNvPr id="14" name="Picture 13" descr="image.png"/>
+          <p:cNvPicPr>
+            <a:picLocks noChangeAspect="1"/>
+          </p:cNvPicPr>
+          <p:nvPr/>
+        </p:nvPicPr>
+        <p:blipFill>
+          <a:blip r:embed="rId3"/>
+          <a:stretch>
+            <a:fillRect/>
+          </a:stretch>
+        </p:blipFill>
+        <p:spPr>
+          <a:xfrm>
+            <a:off x="838200" y="11582400"/>
+            <a:ext cx="438150" cy="438150"/>
+          </a:xfrm>
+          <a:prstGeom prst="rect">
+            <a:avLst/>
+          </a:prstGeom>
+        </p:spPr>
+      </p:pic>
+      <p:sp>
+        <p:nvSpPr>
+          <p:cNvPr id="15" name="TextBox 14"/>
           <p:cNvSpPr txBox="1"/>
           <p:nvPr/>
         </p:nvSpPr>
@@ -3601,7 +3925,7 @@
             <a:r>
               <a:rPr sz="1800" b="1" spc="252">
                 <a:solidFill>
-                  <a:srgbClr val="062A4D"/>
+                  <a:srgbClr val="1657D0"/>
                 </a:solidFill>
                 <a:latin typeface="Figtree"/>
               </a:rPr>
@@ -3610,7 +3934,7 @@
             <a:r>
               <a:rPr sz="1800" b="1" spc="252">
                 <a:solidFill>
-                  <a:srgbClr val="062A4D"/>
+                  <a:srgbClr val="1657D0"/>
                 </a:solidFill>
                 <a:latin typeface="Figtree"/>
               </a:rPr>
@@ -3653,7 +3977,7 @@
         </p:nvSpPr>
         <p:spPr>
           <a:xfrm>
-            <a:off x="838200" y="942975"/>
+            <a:off x="838200" y="838200"/>
             <a:ext cx="381000" cy="47625"/>
           </a:xfrm>
           <a:prstGeom prst="roundRect">
@@ -3693,61 +4017,20 @@
       </p:sp>
       <p:sp>
         <p:nvSpPr>
-          <p:cNvPr id="3" name="TextBox 2"/>
-          <p:cNvSpPr txBox="1"/>
+          <p:cNvPr id="3" name="Rectangle 2"/>
+          <p:cNvSpPr/>
           <p:nvPr/>
         </p:nvSpPr>
         <p:spPr>
           <a:xfrm>
-            <a:off x="1371600" y="838200"/>
-            <a:ext cx="3103959" cy="333375"/>
+            <a:off x="838200" y="6468373"/>
+            <a:ext cx="3775174" cy="253746"/>
           </a:xfrm>
           <a:prstGeom prst="rect">
             <a:avLst/>
           </a:prstGeom>
-          <a:noFill/>
-        </p:spPr>
-        <p:txBody>
-          <a:bodyPr wrap="none" lIns="0" rIns="0" tIns="0" bIns="0" anchor="t">
-            <a:noAutofit/>
-          </a:bodyPr>
-          <a:lstStyle/>
-          <a:p>
-            <a:pPr algn="l">
-              <a:lnSpc>
-                <a:spcPts val="0"/>
-              </a:lnSpc>
-            </a:pPr>
-            <a:r>
-              <a:rPr sz="1650" b="1" spc="264">
-                <a:solidFill>
-                  <a:srgbClr val="1657D0"/>
-                </a:solidFill>
-                <a:latin typeface="Figtree"/>
-              </a:rPr>
-              <a:t xml:space="preserve">QUÉ CONSTRUIMOS</a:t>
-            </a:r>
-          </a:p>
-        </p:txBody>
-      </p:sp>
-      <p:sp>
-        <p:nvSpPr>
-          <p:cNvPr id="4" name="Rounded Rectangle 3"/>
-          <p:cNvSpPr/>
-          <p:nvPr/>
-        </p:nvSpPr>
-        <p:spPr>
-          <a:xfrm>
-            <a:off x="5638800" y="3126878"/>
-            <a:ext cx="495300" cy="38100"/>
-          </a:xfrm>
-          <a:prstGeom prst="roundRect">
-            <a:avLst>
-              <a:gd name="adj" fmla="val 50000"/>
-            </a:avLst>
-          </a:prstGeom>
           <a:solidFill>
-            <a:srgbClr val="00A8E8"/>
+            <a:srgbClr val="A8E1F8"/>
           </a:solidFill>
           <a:ln>
             <a:noFill/>
@@ -3778,14 +4061,94 @@
       </p:sp>
       <p:sp>
         <p:nvSpPr>
+          <p:cNvPr id="4" name="TextBox 3"/>
+          <p:cNvSpPr txBox="1"/>
+          <p:nvPr/>
+        </p:nvSpPr>
+        <p:spPr>
+          <a:xfrm>
+            <a:off x="838200" y="4503390"/>
+            <a:ext cx="9182100" cy="2232719"/>
+          </a:xfrm>
+          <a:prstGeom prst="rect">
+            <a:avLst/>
+          </a:prstGeom>
+          <a:noFill/>
+        </p:spPr>
+        <p:txBody>
+          <a:bodyPr wrap="none" lIns="0" rIns="0" tIns="0" bIns="0" anchor="t">
+            <a:noAutofit/>
+          </a:bodyPr>
+          <a:lstStyle/>
+          <a:p>
+            <a:pPr algn="l">
+              <a:lnSpc>
+                <a:spcPts val="5661"/>
+              </a:lnSpc>
+            </a:pPr>
+            <a:r>
+              <a:rPr sz="5550" b="1" spc="-166">
+                <a:solidFill>
+                  <a:srgbClr val="0A1B33"/>
+                </a:solidFill>
+                <a:latin typeface="Bricolage Grotesque"/>
+              </a:rPr>
+              <a:t xml:space="preserve">Ahora cualquiera</a:t>
+            </a:r>
+          </a:p>
+          <a:p>
+            <a:pPr algn="l">
+              <a:lnSpc>
+                <a:spcPts val="5661"/>
+              </a:lnSpc>
+            </a:pPr>
+            <a:r>
+              <a:rPr sz="5550" b="1" spc="-166">
+                <a:solidFill>
+                  <a:srgbClr val="0A1B33"/>
+                </a:solidFill>
+                <a:latin typeface="Bricolage Grotesque"/>
+              </a:rPr>
+              <a:t xml:space="preserve">que chocó la moto</a:t>
+            </a:r>
+          </a:p>
+          <a:p>
+            <a:pPr algn="l">
+              <a:lnSpc>
+                <a:spcPts val="5661"/>
+              </a:lnSpc>
+            </a:pPr>
+            <a:r>
+              <a:rPr sz="5550" b="1" spc="-166">
+                <a:solidFill>
+                  <a:srgbClr val="0A1B33"/>
+                </a:solidFill>
+                <a:latin typeface="Bricolage Grotesque"/>
+              </a:rPr>
+              <a:t xml:space="preserve">lo encuentra</a:t>
+            </a:r>
+            <a:r>
+              <a:rPr sz="5550" b="1" spc="-166">
+                <a:solidFill>
+                  <a:srgbClr val="0A1B33"/>
+                </a:solidFill>
+                <a:latin typeface="Bricolage Grotesque"/>
+              </a:rPr>
+              <a:t xml:space="preserve">.</a:t>
+            </a:r>
+          </a:p>
+        </p:txBody>
+      </p:sp>
+      <p:sp>
+        <p:nvSpPr>
           <p:cNvPr id="5" name="Rounded Rectangle 4"/>
           <p:cNvSpPr/>
           <p:nvPr/>
         </p:nvSpPr>
         <p:spPr>
           <a:xfrm>
-            <a:off x="5638800" y="6100316"/>
-            <a:ext cx="495300" cy="38100"/>
+            <a:off x="838200" y="7079009"/>
+            <a:ext cx="5870376" cy="885825"/>
           </a:xfrm>
           <a:prstGeom prst="roundRect">
             <a:avLst>
@@ -3793,7 +4156,7 @@
             </a:avLst>
           </a:prstGeom>
           <a:solidFill>
-            <a:srgbClr val="00A8E8"/>
+            <a:srgbClr val="1657D0"/>
           </a:solidFill>
           <a:ln>
             <a:noFill/>
@@ -3824,631 +4187,13 @@
       </p:sp>
       <p:sp>
         <p:nvSpPr>
-          <p:cNvPr id="6" name="Rounded Rectangle 5"/>
-          <p:cNvSpPr/>
-          <p:nvPr/>
-        </p:nvSpPr>
-        <p:spPr>
-          <a:xfrm>
-            <a:off x="5638800" y="8425755"/>
-            <a:ext cx="495300" cy="38100"/>
-          </a:xfrm>
-          <a:prstGeom prst="roundRect">
-            <a:avLst>
-              <a:gd name="adj" fmla="val 50000"/>
-            </a:avLst>
-          </a:prstGeom>
-          <a:solidFill>
-            <a:srgbClr val="00A8E8"/>
-          </a:solidFill>
-          <a:ln>
-            <a:noFill/>
-          </a:ln>
-          <a:effectLst/>
-        </p:spPr>
-        <p:style>
-          <a:lnRef idx="1">
-            <a:schemeClr val="accent1"/>
-          </a:lnRef>
-          <a:fillRef idx="3">
-            <a:schemeClr val="accent1"/>
-          </a:fillRef>
-          <a:effectRef idx="2">
-            <a:schemeClr val="accent1"/>
-          </a:effectRef>
-          <a:fontRef idx="minor">
-            <a:schemeClr val="lt1"/>
-          </a:fontRef>
-        </p:style>
-        <p:txBody>
-          <a:bodyPr rtlCol="0" anchor="ctr"/>
-          <a:lstStyle/>
-          <a:p>
-            <a:pPr algn="ctr"/>
-          </a:p>
-        </p:txBody>
-      </p:sp>
-      <p:sp>
-        <p:nvSpPr>
-          <p:cNvPr id="7" name="TextBox 6"/>
-          <p:cNvSpPr txBox="1"/>
-          <p:nvPr/>
-        </p:nvSpPr>
-        <p:spPr>
-          <a:xfrm>
-            <a:off x="6324600" y="2955428"/>
-            <a:ext cx="3181350" cy="820042"/>
-          </a:xfrm>
-          <a:prstGeom prst="rect">
-            <a:avLst/>
-          </a:prstGeom>
-          <a:noFill/>
-        </p:spPr>
-        <p:txBody>
-          <a:bodyPr wrap="square" lIns="0" rIns="0" tIns="0" bIns="0" anchor="t">
-            <a:noAutofit/>
-          </a:bodyPr>
-          <a:lstStyle/>
-          <a:p>
-            <a:pPr algn="l">
-              <a:lnSpc>
-                <a:spcPts val="2929"/>
-              </a:lnSpc>
-            </a:pPr>
-            <a:r>
-              <a:rPr sz="2325" b="1">
-                <a:solidFill>
-                  <a:srgbClr val="0A1B33"/>
-                </a:solidFill>
-                <a:latin typeface="Figtree"/>
-              </a:rPr>
-              <a:t xml:space="preserve">La sección de seguros, con su propio botón</a:t>
-            </a:r>
-          </a:p>
-        </p:txBody>
-      </p:sp>
-      <p:sp>
-        <p:nvSpPr>
-          <p:cNvPr id="8" name="TextBox 7"/>
-          <p:cNvSpPr txBox="1"/>
-          <p:nvPr/>
-        </p:nvSpPr>
-        <p:spPr>
-          <a:xfrm>
-            <a:off x="6324600" y="5928866"/>
-            <a:ext cx="3181350" cy="820042"/>
-          </a:xfrm>
-          <a:prstGeom prst="rect">
-            <a:avLst/>
-          </a:prstGeom>
-          <a:noFill/>
-        </p:spPr>
-        <p:txBody>
-          <a:bodyPr wrap="square" lIns="0" rIns="0" tIns="0" bIns="0" anchor="t">
-            <a:noAutofit/>
-          </a:bodyPr>
-          <a:lstStyle/>
-          <a:p>
-            <a:pPr algn="l">
-              <a:lnSpc>
-                <a:spcPts val="2929"/>
-              </a:lnSpc>
-            </a:pPr>
-            <a:r>
-              <a:rPr sz="2325" b="1">
-                <a:solidFill>
-                  <a:srgbClr val="0A1B33"/>
-                </a:solidFill>
-                <a:latin typeface="Figtree"/>
-              </a:rPr>
-              <a:t xml:space="preserve">Informe con fotos de cada daño</a:t>
-            </a:r>
-          </a:p>
-        </p:txBody>
-      </p:sp>
-      <p:sp>
-        <p:nvSpPr>
-          <p:cNvPr id="9" name="TextBox 8"/>
-          <p:cNvSpPr txBox="1"/>
-          <p:nvPr/>
-        </p:nvSpPr>
-        <p:spPr>
-          <a:xfrm>
-            <a:off x="6324600" y="8254305"/>
-            <a:ext cx="3181350" cy="820042"/>
-          </a:xfrm>
-          <a:prstGeom prst="rect">
-            <a:avLst/>
-          </a:prstGeom>
-          <a:noFill/>
-        </p:spPr>
-        <p:txBody>
-          <a:bodyPr wrap="square" lIns="0" rIns="0" tIns="0" bIns="0" anchor="t">
-            <a:noAutofit/>
-          </a:bodyPr>
-          <a:lstStyle/>
-          <a:p>
-            <a:pPr algn="l">
-              <a:lnSpc>
-                <a:spcPts val="2929"/>
-              </a:lnSpc>
-            </a:pPr>
-            <a:r>
-              <a:rPr sz="2325" b="1">
-                <a:solidFill>
-                  <a:srgbClr val="0A1B33"/>
-                </a:solidFill>
-                <a:latin typeface="Figtree"/>
-              </a:rPr>
-              <a:t xml:space="preserve">“Atendemos siniestros de toda la zona oeste”</a:t>
-            </a:r>
-          </a:p>
-        </p:txBody>
-      </p:sp>
-      <p:sp>
-        <p:nvSpPr>
-          <p:cNvPr id="10" name="TextBox 9"/>
-          <p:cNvSpPr txBox="1"/>
-          <p:nvPr/>
-        </p:nvSpPr>
-        <p:spPr>
-          <a:xfrm>
-            <a:off x="6324600" y="3775471"/>
-            <a:ext cx="3181350" cy="1696194"/>
-          </a:xfrm>
-          <a:prstGeom prst="rect">
-            <a:avLst/>
-          </a:prstGeom>
-          <a:noFill/>
-        </p:spPr>
-        <p:txBody>
-          <a:bodyPr wrap="square" lIns="0" rIns="0" tIns="0" bIns="0" anchor="t">
-            <a:noAutofit/>
-          </a:bodyPr>
-          <a:lstStyle/>
-          <a:p>
-            <a:pPr algn="l">
-              <a:lnSpc>
-                <a:spcPts val="2551"/>
-              </a:lnSpc>
-            </a:pPr>
-            <a:r>
-              <a:rPr sz="2025" b="0">
-                <a:solidFill>
-                  <a:srgbClr val="46526B"/>
-                </a:solidFill>
-                <a:latin typeface="Figtree"/>
-              </a:rPr>
-              <a:t xml:space="preserve">Presupuesto con la mano de obra y los repuestos discriminados, en el formato que pide la compañía.</a:t>
-            </a:r>
-          </a:p>
-        </p:txBody>
-      </p:sp>
-      <p:sp>
-        <p:nvSpPr>
-          <p:cNvPr id="11" name="TextBox 10"/>
-          <p:cNvSpPr txBox="1"/>
-          <p:nvPr/>
-        </p:nvSpPr>
-        <p:spPr>
-          <a:xfrm>
-            <a:off x="6324600" y="6748908"/>
-            <a:ext cx="3181350" cy="1048196"/>
-          </a:xfrm>
-          <a:prstGeom prst="rect">
-            <a:avLst/>
-          </a:prstGeom>
-          <a:noFill/>
-        </p:spPr>
-        <p:txBody>
-          <a:bodyPr wrap="square" lIns="0" rIns="0" tIns="0" bIns="0" anchor="t">
-            <a:noAutofit/>
-          </a:bodyPr>
-          <a:lstStyle/>
-          <a:p>
-            <a:pPr algn="l">
-              <a:lnSpc>
-                <a:spcPts val="2551"/>
-              </a:lnSpc>
-            </a:pPr>
-            <a:r>
-              <a:rPr sz="2025" b="0">
-                <a:solidFill>
-                  <a:srgbClr val="46526B"/>
-                </a:solidFill>
-                <a:latin typeface="Figtree"/>
-              </a:rPr>
-              <a:t xml:space="preserve">Para que la aseguradora autorice la reparación sin idas y vueltas.</a:t>
-            </a:r>
-          </a:p>
-        </p:txBody>
-      </p:sp>
-      <p:sp>
-        <p:nvSpPr>
-          <p:cNvPr id="12" name="TextBox 11"/>
-          <p:cNvSpPr txBox="1"/>
-          <p:nvPr/>
-        </p:nvSpPr>
-        <p:spPr>
-          <a:xfrm>
-            <a:off x="6324600" y="9074348"/>
-            <a:ext cx="3181350" cy="724197"/>
-          </a:xfrm>
-          <a:prstGeom prst="rect">
-            <a:avLst/>
-          </a:prstGeom>
-          <a:noFill/>
-        </p:spPr>
-        <p:txBody>
-          <a:bodyPr wrap="square" lIns="0" rIns="0" tIns="0" bIns="0" anchor="t">
-            <a:noAutofit/>
-          </a:bodyPr>
-          <a:lstStyle/>
-          <a:p>
-            <a:pPr algn="l">
-              <a:lnSpc>
-                <a:spcPts val="2551"/>
-              </a:lnSpc>
-            </a:pPr>
-            <a:r>
-              <a:rPr sz="2025" b="0">
-                <a:solidFill>
-                  <a:srgbClr val="46526B"/>
-                </a:solidFill>
-                <a:latin typeface="Figtree"/>
-              </a:rPr>
-              <a:t xml:space="preserve">Escrito en la página, no en la cabeza del mecánico.</a:t>
-            </a:r>
-          </a:p>
-        </p:txBody>
-      </p:sp>
-      <p:pic>
-        <p:nvPicPr>
-          <p:cNvPr id="13" name="Picture 12" descr="image.png"/>
-          <p:cNvPicPr>
-            <a:picLocks noChangeAspect="1"/>
-          </p:cNvPicPr>
-          <p:nvPr/>
-        </p:nvPicPr>
-        <p:blipFill>
-          <a:blip r:embed="rId2"/>
-          <a:stretch>
-            <a:fillRect/>
-          </a:stretch>
-        </p:blipFill>
-        <p:spPr>
-          <a:xfrm>
-            <a:off x="674515" y="1954124"/>
-            <a:ext cx="4632668" cy="8769525"/>
-          </a:xfrm>
-          <a:prstGeom prst="rect">
-            <a:avLst/>
-          </a:prstGeom>
-        </p:spPr>
-      </p:pic>
-      <p:pic>
-        <p:nvPicPr>
-          <p:cNvPr id="14" name="Picture 13" descr="image.png"/>
-          <p:cNvPicPr>
-            <a:picLocks noChangeAspect="1"/>
-          </p:cNvPicPr>
-          <p:nvPr/>
-        </p:nvPicPr>
-        <p:blipFill>
-          <a:blip r:embed="rId3"/>
-          <a:stretch>
-            <a:fillRect/>
-          </a:stretch>
-        </p:blipFill>
-        <p:spPr>
-          <a:xfrm>
-            <a:off x="838200" y="11582400"/>
-            <a:ext cx="438150" cy="438150"/>
-          </a:xfrm>
-          <a:prstGeom prst="rect">
-            <a:avLst/>
-          </a:prstGeom>
-        </p:spPr>
-      </p:pic>
-      <p:sp>
-        <p:nvSpPr>
-          <p:cNvPr id="15" name="TextBox 14"/>
-          <p:cNvSpPr txBox="1"/>
-          <p:nvPr/>
-        </p:nvSpPr>
-        <p:spPr>
-          <a:xfrm>
-            <a:off x="7955756" y="11663362"/>
-            <a:ext cx="2064543" cy="352425"/>
-          </a:xfrm>
-          <a:prstGeom prst="rect">
-            <a:avLst/>
-          </a:prstGeom>
-          <a:noFill/>
-        </p:spPr>
-        <p:txBody>
-          <a:bodyPr wrap="none" lIns="0" rIns="0" tIns="0" bIns="0" anchor="t">
-            <a:noAutofit/>
-          </a:bodyPr>
-          <a:lstStyle/>
-          <a:p>
-            <a:pPr algn="l">
-              <a:lnSpc>
-                <a:spcPts val="0"/>
-              </a:lnSpc>
-            </a:pPr>
-            <a:r>
-              <a:rPr sz="1800" b="1" spc="252">
-                <a:solidFill>
-                  <a:srgbClr val="1657D0"/>
-                </a:solidFill>
-                <a:latin typeface="Figtree"/>
-              </a:rPr>
-              <a:t xml:space="preserve">DESLIZÁ </a:t>
-            </a:r>
-            <a:r>
-              <a:rPr sz="1800" b="1" spc="252">
-                <a:solidFill>
-                  <a:srgbClr val="1657D0"/>
-                </a:solidFill>
-                <a:latin typeface="Figtree"/>
-              </a:rPr>
-              <a:t xml:space="preserve"> →</a:t>
-            </a:r>
-          </a:p>
-        </p:txBody>
-      </p:sp>
-    </p:spTree>
-  </p:cSld>
-  <p:clrMapOvr>
-    <a:masterClrMapping/>
-  </p:clrMapOvr>
-</p:sld>
-</file>
-
-<file path=ppt/slides/slide4.xml><?xml version="1.0" encoding="utf-8"?>
-<p:sld xmlns:a="http://schemas.openxmlformats.org/drawingml/2006/main" xmlns:p="http://schemas.openxmlformats.org/presentationml/2006/main" xmlns:r="http://schemas.openxmlformats.org/officeDocument/2006/relationships">
-  <p:cSld>
-    <p:bg>
-      <p:bgPr>
-        <a:solidFill>
-          <a:srgbClr val="FFFFFF"/>
-        </a:solidFill>
-        <a:effectLst/>
-      </p:bgPr>
-    </p:bg>
-    <p:spTree>
-      <p:nvGrpSpPr>
-        <p:cNvPr id="1" name=""/>
-        <p:cNvGrpSpPr/>
-        <p:nvPr/>
-      </p:nvGrpSpPr>
-      <p:grpSpPr/>
-      <p:sp>
-        <p:nvSpPr>
-          <p:cNvPr id="2" name="Rounded Rectangle 1"/>
-          <p:cNvSpPr/>
-          <p:nvPr/>
-        </p:nvSpPr>
-        <p:spPr>
-          <a:xfrm>
-            <a:off x="838200" y="838200"/>
-            <a:ext cx="381000" cy="47625"/>
-          </a:xfrm>
-          <a:prstGeom prst="roundRect">
-            <a:avLst>
-              <a:gd name="adj" fmla="val 50000"/>
-            </a:avLst>
-          </a:prstGeom>
-          <a:solidFill>
-            <a:srgbClr val="00A8E8"/>
-          </a:solidFill>
-          <a:ln>
-            <a:noFill/>
-          </a:ln>
-          <a:effectLst/>
-        </p:spPr>
-        <p:style>
-          <a:lnRef idx="1">
-            <a:schemeClr val="accent1"/>
-          </a:lnRef>
-          <a:fillRef idx="3">
-            <a:schemeClr val="accent1"/>
-          </a:fillRef>
-          <a:effectRef idx="2">
-            <a:schemeClr val="accent1"/>
-          </a:effectRef>
-          <a:fontRef idx="minor">
-            <a:schemeClr val="lt1"/>
-          </a:fontRef>
-        </p:style>
-        <p:txBody>
-          <a:bodyPr rtlCol="0" anchor="ctr"/>
-          <a:lstStyle/>
-          <a:p>
-            <a:pPr algn="ctr"/>
-          </a:p>
-        </p:txBody>
-      </p:sp>
-      <p:sp>
-        <p:nvSpPr>
-          <p:cNvPr id="3" name="Rectangle 2"/>
-          <p:cNvSpPr/>
-          <p:nvPr/>
-        </p:nvSpPr>
-        <p:spPr>
-          <a:xfrm>
-            <a:off x="838200" y="6684514"/>
-            <a:ext cx="4693443" cy="315468"/>
-          </a:xfrm>
-          <a:prstGeom prst="rect">
-            <a:avLst/>
-          </a:prstGeom>
-          <a:solidFill>
-            <a:srgbClr val="A8E1F8"/>
-          </a:solidFill>
-          <a:ln>
-            <a:noFill/>
-          </a:ln>
-          <a:effectLst/>
-        </p:spPr>
-        <p:style>
-          <a:lnRef idx="1">
-            <a:schemeClr val="accent1"/>
-          </a:lnRef>
-          <a:fillRef idx="3">
-            <a:schemeClr val="accent1"/>
-          </a:fillRef>
-          <a:effectRef idx="2">
-            <a:schemeClr val="accent1"/>
-          </a:effectRef>
-          <a:fontRef idx="minor">
-            <a:schemeClr val="lt1"/>
-          </a:fontRef>
-        </p:style>
-        <p:txBody>
-          <a:bodyPr rtlCol="0" anchor="ctr"/>
-          <a:lstStyle/>
-          <a:p>
-            <a:pPr algn="ctr"/>
-          </a:p>
-        </p:txBody>
-      </p:sp>
-      <p:sp>
-        <p:nvSpPr>
-          <p:cNvPr id="4" name="TextBox 3"/>
-          <p:cNvSpPr txBox="1"/>
-          <p:nvPr/>
-        </p:nvSpPr>
-        <p:spPr>
-          <a:xfrm>
-            <a:off x="838200" y="4241006"/>
-            <a:ext cx="9182100" cy="2757338"/>
-          </a:xfrm>
-          <a:prstGeom prst="rect">
-            <a:avLst/>
-          </a:prstGeom>
-          <a:noFill/>
-        </p:spPr>
-        <p:txBody>
-          <a:bodyPr wrap="none" lIns="0" rIns="0" tIns="0" bIns="0" anchor="t">
-            <a:noAutofit/>
-          </a:bodyPr>
-          <a:lstStyle/>
-          <a:p>
-            <a:pPr algn="l">
-              <a:lnSpc>
-                <a:spcPts val="7038"/>
-              </a:lnSpc>
-            </a:pPr>
-            <a:r>
-              <a:rPr sz="6900" b="1" spc="-206">
-                <a:solidFill>
-                  <a:srgbClr val="0A1B33"/>
-                </a:solidFill>
-                <a:latin typeface="Bricolage Grotesque"/>
-              </a:rPr>
-              <a:t xml:space="preserve">Ahora el que tuvo</a:t>
-            </a:r>
-          </a:p>
-          <a:p>
-            <a:pPr algn="l">
-              <a:lnSpc>
-                <a:spcPts val="7038"/>
-              </a:lnSpc>
-            </a:pPr>
-            <a:r>
-              <a:rPr sz="6900" b="1" spc="-206">
-                <a:solidFill>
-                  <a:srgbClr val="0A1B33"/>
-                </a:solidFill>
-                <a:latin typeface="Bricolage Grotesque"/>
-              </a:rPr>
-              <a:t xml:space="preserve">un siniestro</a:t>
-            </a:r>
-          </a:p>
-          <a:p>
-            <a:pPr algn="l">
-              <a:lnSpc>
-                <a:spcPts val="7038"/>
-              </a:lnSpc>
-            </a:pPr>
-            <a:r>
-              <a:rPr sz="6900" b="1" spc="-206">
-                <a:solidFill>
-                  <a:srgbClr val="0A1B33"/>
-                </a:solidFill>
-                <a:latin typeface="Bricolage Grotesque"/>
-              </a:rPr>
-              <a:t xml:space="preserve">lo encuentra</a:t>
-            </a:r>
-            <a:r>
-              <a:rPr sz="6900" b="1" spc="-206">
-                <a:solidFill>
-                  <a:srgbClr val="0A1B33"/>
-                </a:solidFill>
-                <a:latin typeface="Bricolage Grotesque"/>
-              </a:rPr>
-              <a:t xml:space="preserve">.</a:t>
-            </a:r>
-          </a:p>
-        </p:txBody>
-      </p:sp>
-      <p:sp>
-        <p:nvSpPr>
-          <p:cNvPr id="5" name="Rounded Rectangle 4"/>
-          <p:cNvSpPr/>
-          <p:nvPr/>
-        </p:nvSpPr>
-        <p:spPr>
-          <a:xfrm>
-            <a:off x="838200" y="7341244"/>
-            <a:ext cx="5870376" cy="885825"/>
-          </a:xfrm>
-          <a:prstGeom prst="roundRect">
-            <a:avLst>
-              <a:gd name="adj" fmla="val 50000"/>
-            </a:avLst>
-          </a:prstGeom>
-          <a:solidFill>
-            <a:srgbClr val="1657D0"/>
-          </a:solidFill>
-          <a:ln>
-            <a:noFill/>
-          </a:ln>
-          <a:effectLst/>
-        </p:spPr>
-        <p:style>
-          <a:lnRef idx="1">
-            <a:schemeClr val="accent1"/>
-          </a:lnRef>
-          <a:fillRef idx="3">
-            <a:schemeClr val="accent1"/>
-          </a:fillRef>
-          <a:effectRef idx="2">
-            <a:schemeClr val="accent1"/>
-          </a:effectRef>
-          <a:fontRef idx="minor">
-            <a:schemeClr val="lt1"/>
-          </a:fontRef>
-        </p:style>
-        <p:txBody>
-          <a:bodyPr rtlCol="0" anchor="ctr"/>
-          <a:lstStyle/>
-          <a:p>
-            <a:pPr algn="ctr"/>
-          </a:p>
-        </p:txBody>
-      </p:sp>
-      <p:sp>
-        <p:nvSpPr>
           <p:cNvPr id="6" name="TextBox 5"/>
           <p:cNvSpPr txBox="1"/>
           <p:nvPr/>
         </p:nvSpPr>
         <p:spPr>
           <a:xfrm>
-            <a:off x="1257300" y="7607944"/>
+            <a:off x="1257300" y="7345709"/>
             <a:ext cx="5194101" cy="428625"/>
           </a:xfrm>
           <a:prstGeom prst="rect">

</xml_diff>